<commit_message>
Draw a slide's bullets set in Wingdings, Symbol or Webdings as characters a phone has, where some were empty boxes or the letter l, from tables now shared with the prose reader
</commit_message>
<xml_diff>
--- a/tests/fixtures/files/symbol-bullets.pptx
+++ b/tests/fixtures/files/symbol-bullets.pptx
@@ -6,6 +6,7 @@
   </p:sldMasterIdLst>
   <p:sldIdLst>
     <p:sldId id="256" r:id="rId7"/>
+    <p:sldId id="257" r:id="rId8"/>
   </p:sldIdLst>
   <p:sldSz cx="9144000" cy="6858000" type="screen4x3"/>
   <p:notesSz cx="6858000" cy="9144000"/>
@@ -2847,8 +2848,8 @@
         <a:spcBef>
           <a:spcPct val="20000"/>
         </a:spcBef>
-        <a:buFont typeface="Arial"/>
-        <a:buChar char="•"/>
+        <a:buFont typeface="Wingdings"/>
+        <a:buChar char="l"/>
         <a:defRPr sz="3200" kern="1200">
           <a:solidFill>
             <a:schemeClr val="tx1"/>
@@ -3096,8 +3097,8 @@
         </p:nvSpPr>
         <p:spPr>
           <a:xfrm>
-            <a:off x="914400" y="914400"/>
-            <a:ext cx="7315200" cy="1828800"/>
+            <a:off x="914400" y="457200"/>
+            <a:ext cx="7315200" cy="5486400"/>
           </a:xfrm>
           <a:prstGeom prst="rect">
             <a:avLst/>
@@ -3127,6 +3128,126 @@
             <a:r>
               <a:rPr sz="2400"/>
               <a:t>An arrowhead from Wingdings 3</a:t>
+            </a:r>
+          </a:p>
+          <a:p>
+            <a:pPr marL="457200" indent="-457200">
+              <a:buFont typeface="Wingdings"/>
+              <a:buChar char="Ø"/>
+            </a:pPr>
+            <a:r>
+              <a:rPr sz="2400"/>
+              <a:t>The arrow PowerPoint offers</a:t>
+            </a:r>
+          </a:p>
+          <a:p>
+            <a:pPr marL="457200" indent="-457200">
+              <a:buFont typeface="Wingdings"/>
+              <a:buChar char=""/>
+            </a:pPr>
+            <a:r>
+              <a:rPr sz="2400"/>
+              <a:t>A round bullet from Wingdings</a:t>
+            </a:r>
+          </a:p>
+          <a:p>
+            <a:pPr marL="457200" indent="-457200">
+              <a:buFont typeface="Symbol"/>
+              <a:buChar char=""/>
+            </a:pPr>
+            <a:r>
+              <a:rPr sz="2400"/>
+              <a:t>A bullet from Symbol</a:t>
+            </a:r>
+          </a:p>
+          <a:p>
+            <a:pPr marL="457200" indent="-457200">
+              <a:buFont typeface="Webdings"/>
+              <a:buChar char="4"/>
+            </a:pPr>
+            <a:r>
+              <a:rPr sz="2400"/>
+              <a:t>A triangle from Webdings</a:t>
+            </a:r>
+          </a:p>
+          <a:p>
+            <a:pPr marL="457200" indent="-457200">
+              <a:buFont typeface="Wingdings 2"/>
+              <a:buChar char=""/>
+            </a:pPr>
+            <a:r>
+              <a:rPr sz="2400"/>
+              <a:t>A printer from Wingdings 2</a:t>
+            </a:r>
+          </a:p>
+          <a:p>
+            <a:pPr marL="457200" indent="-457200">
+              <a:buFont typeface="StarSymbol"/>
+              <a:buChar char=""/>
+            </a:pPr>
+            <a:r>
+              <a:rPr sz="2400"/>
+              <a:t>A private use bullet from StarSymbol</a:t>
+            </a:r>
+          </a:p>
+        </p:txBody>
+      </p:sp>
+    </p:spTree>
+  </p:cSld>
+  <p:clrMapOvr>
+    <a:masterClrMapping/>
+  </p:clrMapOvr>
+</p:sld>
+</file>
+
+<file path=ppt/slides/slide2.xml><?xml version="1.0" encoding="utf-8"?>
+<p:sld xmlns:a="http://schemas.openxmlformats.org/drawingml/2006/main" xmlns:p="http://schemas.openxmlformats.org/presentationml/2006/main" xmlns:r="http://schemas.openxmlformats.org/officeDocument/2006/relationships">
+  <p:cSld>
+    <p:spTree>
+      <p:nvGrpSpPr>
+        <p:cNvPr id="1" name=""/>
+        <p:cNvGrpSpPr/>
+        <p:nvPr/>
+      </p:nvGrpSpPr>
+      <p:grpSpPr/>
+      <p:sp>
+        <p:nvSpPr>
+          <p:cNvPr id="2" name="Title 1"/>
+          <p:cNvSpPr>
+            <a:spLocks noGrp="1"/>
+          </p:cNvSpPr>
+          <p:nvPr>
+            <p:ph type="title"/>
+          </p:nvPr>
+        </p:nvSpPr>
+        <p:spPr/>
+        <p:txBody>
+          <a:bodyPr/>
+          <a:lstStyle/>
+          <a:p>
+            <a:r>
+              <a:t>From the design</a:t>
+            </a:r>
+          </a:p>
+        </p:txBody>
+      </p:sp>
+      <p:sp>
+        <p:nvSpPr>
+          <p:cNvPr id="3" name="Designed"/>
+          <p:cNvSpPr>
+            <a:spLocks noGrp="1"/>
+          </p:cNvSpPr>
+          <p:nvPr>
+            <p:ph idx="1"/>
+          </p:nvPr>
+        </p:nvSpPr>
+        <p:spPr/>
+        <p:txBody>
+          <a:bodyPr/>
+          <a:lstStyle/>
+          <a:p>
+            <a:r>
+              <a:t>A round bullet from the master</a:t>
             </a:r>
           </a:p>
         </p:txBody>

</xml_diff>

<commit_message>
Draw SmartArt's symbol-font bullets as characters a phone has too, and give PPTXjs its Wingdings 2 and 3 table from symbol-fonts.js rather than shipping upstream's dingbat.js
</commit_message>
<xml_diff>
--- a/tests/fixtures/files/symbol-bullets.pptx
+++ b/tests/fixtures/files/symbol-bullets.pptx
@@ -7,6 +7,7 @@
   <p:sldIdLst>
     <p:sldId id="256" r:id="rId7"/>
     <p:sldId id="257" r:id="rId8"/>
+    <p:sldId id="258" r:id="rId9"/>
   </p:sldIdLst>
   <p:sldSz cx="9144000" cy="6858000" type="screen4x3"/>
   <p:notesSz cx="6858000" cy="9144000"/>
@@ -106,6 +107,92 @@
     </a:lvl9pPr>
   </p:defaultTextStyle>
 </p:presentation>
+</file>
+
+<file path=ppt/diagrams/colors1.xml><?xml version="1.0" encoding="utf-8"?>
+<dgm:colorsDef xmlns:dgm="http://schemas.openxmlformats.org/drawingml/2006/diagram"/>
+</file>
+
+<file path=ppt/diagrams/data1.xml><?xml version="1.0" encoding="utf-8"?>
+<dgm:dataModel xmlns:dgm="http://schemas.openxmlformats.org/drawingml/2006/diagram"/>
+</file>
+
+<file path=ppt/diagrams/drawing1.xml><?xml version="1.0" encoding="utf-8"?>
+<dsp:drawing xmlns:dsp="http://schemas.microsoft.com/office/drawing/2008/diagram" xmlns:a="http://schemas.openxmlformats.org/drawingml/2006/main">
+  <dsp:spTree>
+    <dsp:nvGrpSpPr>
+      <dsp:cNvPr id="0" name=""/>
+      <dsp:cNvGrpSpPr/>
+    </dsp:nvGrpSpPr>
+    <dsp:grpSpPr/>
+    <dsp:sp modelId="{00000000-0000-0000-0000-000000000001}">
+      <dsp:nvSpPr>
+        <dsp:cNvPr id="0" name="Round in SmartArt"/>
+        <dsp:cNvSpPr/>
+      </dsp:nvSpPr>
+      <dsp:spPr>
+        <a:xfrm>
+          <a:off x="0" y="0"/>
+          <a:ext cx="7315200" cy="1371600"/>
+        </a:xfrm>
+        <a:prstGeom prst="rect">
+          <a:avLst/>
+        </a:prstGeom>
+      </dsp:spPr>
+      <dsp:txBody>
+        <a:bodyPr/>
+        <a:lstStyle/>
+        <a:p>
+          <a:pPr marL="457200" indent="-457200">
+            <a:buFont typeface="Wingdings"/>
+            <a:buChar char="l"/>
+          </a:pPr>
+          <a:r>
+            <a:rPr lang="en-US" sz="2400"/>
+            <a:t>A round bullet in SmartArt</a:t>
+          </a:r>
+        </a:p>
+      </dsp:txBody>
+    </dsp:sp>
+    <dsp:sp modelId="{00000000-0000-0000-0000-000000000002}">
+      <dsp:nvSpPr>
+        <dsp:cNvPr id="0" name="Arrowhead in SmartArt"/>
+        <dsp:cNvSpPr/>
+      </dsp:nvSpPr>
+      <dsp:spPr>
+        <a:xfrm>
+          <a:off x="0" y="1371600"/>
+          <a:ext cx="7315200" cy="1371600"/>
+        </a:xfrm>
+        <a:prstGeom prst="rect">
+          <a:avLst/>
+        </a:prstGeom>
+      </dsp:spPr>
+      <dsp:txBody>
+        <a:bodyPr/>
+        <a:lstStyle/>
+        <a:p>
+          <a:pPr marL="457200" indent="-457200">
+            <a:buFont typeface="Wingdings 3"/>
+            <a:buChar char=""/>
+          </a:pPr>
+          <a:r>
+            <a:rPr lang="en-US" sz="2400"/>
+            <a:t>An arrowhead in SmartArt</a:t>
+          </a:r>
+        </a:p>
+      </dsp:txBody>
+    </dsp:sp>
+  </dsp:spTree>
+</dsp:drawing>
+</file>
+
+<file path=ppt/diagrams/layout1.xml><?xml version="1.0" encoding="utf-8"?>
+<dgm:layoutDef xmlns:dgm="http://schemas.openxmlformats.org/drawingml/2006/diagram"/>
+</file>
+
+<file path=ppt/diagrams/quickStyle1.xml><?xml version="1.0" encoding="utf-8"?>
+<dgm:styleDef xmlns:dgm="http://schemas.openxmlformats.org/drawingml/2006/diagram"/>
 </file>
 
 <file path=ppt/slideLayouts/slideLayout1.xml><?xml version="1.0" encoding="utf-8"?>
@@ -3252,6 +3339,40 @@
           </a:p>
         </p:txBody>
       </p:sp>
+    </p:spTree>
+  </p:cSld>
+  <p:clrMapOvr>
+    <a:masterClrMapping/>
+  </p:clrMapOvr>
+</p:sld>
+</file>
+
+<file path=ppt/slides/slide3.xml><?xml version="1.0" encoding="utf-8"?>
+<p:sld xmlns:a="http://schemas.openxmlformats.org/drawingml/2006/main" xmlns:p="http://schemas.openxmlformats.org/presentationml/2006/main" xmlns:r="http://schemas.openxmlformats.org/officeDocument/2006/relationships">
+  <p:cSld>
+    <p:spTree>
+      <p:nvGrpSpPr>
+        <p:cNvPr id="1" name=""/>
+        <p:cNvGrpSpPr/>
+        <p:nvPr/>
+      </p:nvGrpSpPr>
+      <p:grpSpPr/>
+      <p:graphicFrame>
+        <p:nvGraphicFramePr>
+          <p:cNvPr id="2" name="SmartArt"/>
+          <p:cNvGraphicFramePr/>
+          <p:nvPr/>
+        </p:nvGraphicFramePr>
+        <p:xfrm>
+          <a:off x="914400" y="1371600"/>
+          <a:ext cx="7315200" cy="2743200"/>
+        </p:xfrm>
+        <a:graphic>
+          <a:graphicData uri="http://schemas.openxmlformats.org/drawingml/2006/diagram">
+            <dgm:relIds xmlns:dgm="http://schemas.openxmlformats.org/drawingml/2006/diagram" r:dm="rId2" r:lo="rId3" r:qs="rId4" r:cs="rId5"/>
+          </a:graphicData>
+        </a:graphic>
+      </p:graphicFrame>
     </p:spTree>
   </p:cSld>
   <p:clrMapOvr>

</xml_diff>